<commit_message>
fix: correct PPTX template cloning, TOC filling, image relationships and dual layout handling
- Fix off-by-one template index mapping (table/table-image now point to slide 7)
- Fix clone cleanup loop to delete original templates (2-7) instead of first clone
- Preserve picture rIds during slide cloning so logos render correctly
- Fix TOC filler to recognize two-digit entry numbers (01, 02...)
- Fix fill_dual to ignore decorative bars/footer and locate summary box
- Support descriptive image captions when image files are missing
- Update SKILL.md templates with h1 titles, HTML lists/tables, single-page TOC
- Fix CSS background-image paths for HTML preview logo rendering
</commit_message>
<xml_diff>
--- a/templates/template.pptx
+++ b/templates/template.pptx
@@ -5,10 +5,10 @@
     <p:sldMasterId id="2147483648" r:id="rId1"/>
   </p:sldMasterIdLst>
   <p:notesMasterIdLst>
-    <p:notesMasterId r:id="rId12"/>
+    <p:notesMasterId r:id="rId11"/>
   </p:notesMasterIdLst>
   <p:handoutMasterIdLst>
-    <p:handoutMasterId r:id="rId13"/>
+    <p:handoutMasterId r:id="rId12"/>
   </p:handoutMasterIdLst>
   <p:sldIdLst>
     <p:sldId id="627" r:id="rId2"/>
@@ -18,9 +18,8 @@
     <p:sldId id="1124" r:id="rId6"/>
     <p:sldId id="1125" r:id="rId7"/>
     <p:sldId id="1126" r:id="rId8"/>
-    <p:sldId id="1127" r:id="rId9"/>
-    <p:sldId id="1128" r:id="rId10"/>
-    <p:sldId id="608" r:id="rId11"/>
+    <p:sldId id="1128" r:id="rId9"/>
+    <p:sldId id="608" r:id="rId10"/>
   </p:sldIdLst>
   <p:sldSz cx="12192000" cy="6858000"/>
   <p:notesSz cx="6858000" cy="9144000"/>
@@ -4465,191 +4464,6 @@
 </p:sld>
 </file>
 
-<file path=ppt/slides/slide10.xml><?xml version="1.0" encoding="utf-8"?>
-<p:sld xmlns:a="http://schemas.openxmlformats.org/drawingml/2006/main" xmlns:r="http://schemas.openxmlformats.org/officeDocument/2006/relationships" xmlns:p="http://schemas.openxmlformats.org/presentationml/2006/main">
-  <p:cSld>
-    <p:spTree>
-      <p:nvGrpSpPr>
-        <p:cNvPr id="1" name=""/>
-        <p:cNvGrpSpPr/>
-        <p:nvPr/>
-      </p:nvGrpSpPr>
-      <p:grpSpPr>
-        <a:xfrm>
-          <a:off x="0" y="0"/>
-          <a:ext cx="0" cy="0"/>
-          <a:chOff x="0" y="0"/>
-          <a:chExt cx="0" cy="0"/>
-        </a:xfrm>
-      </p:grpSpPr>
-      <p:sp>
-        <p:nvSpPr>
-          <p:cNvPr id="7" name="文本框 6">
-            <a:extLst>
-              <a:ext uri="{FF2B5EF4-FFF2-40B4-BE49-F238E27FC236}">
-                <a16:creationId xmlns:a16="http://schemas.microsoft.com/office/drawing/2014/main" id="{66A19AAD-1CDF-4899-8D9B-772D397CF09A}"/>
-              </a:ext>
-            </a:extLst>
-          </p:cNvPr>
-          <p:cNvSpPr txBox="1"/>
-          <p:nvPr/>
-        </p:nvSpPr>
-        <p:spPr>
-          <a:xfrm>
-            <a:off x="2170700" y="2395120"/>
-            <a:ext cx="9758680" cy="1323439"/>
-          </a:xfrm>
-          <a:prstGeom prst="rect">
-            <a:avLst/>
-          </a:prstGeom>
-          <a:noFill/>
-        </p:spPr>
-        <p:txBody>
-          <a:bodyPr wrap="square" rtlCol="0">
-            <a:spAutoFit/>
-          </a:bodyPr>
-          <a:lstStyle/>
-          <a:p>
-            <a:pPr algn="ctr"/>
-            <a:r>
-              <a:rPr lang="en-US" altLang="zh-CN" sz="8000" dirty="0">
-                <a:gradFill>
-                  <a:gsLst>
-                    <a:gs pos="0">
-                      <a:schemeClr val="accent1"/>
-                    </a:gs>
-                    <a:gs pos="100000">
-                      <a:schemeClr val="bg1">
-                        <a:alpha val="0"/>
-                      </a:schemeClr>
-                    </a:gs>
-                  </a:gsLst>
-                  <a:lin ang="5400000" scaled="1"/>
-                </a:gradFill>
-                <a:latin typeface="Impact" panose="020B0806030902050204" pitchFamily="34" charset="0"/>
-              </a:rPr>
-              <a:t>THANKS FOR LISTENING</a:t>
-            </a:r>
-            <a:endParaRPr lang="zh-CN" altLang="en-US" sz="8000" dirty="0">
-              <a:gradFill>
-                <a:gsLst>
-                  <a:gs pos="0">
-                    <a:schemeClr val="accent1"/>
-                  </a:gs>
-                  <a:gs pos="100000">
-                    <a:schemeClr val="bg1">
-                      <a:alpha val="0"/>
-                    </a:schemeClr>
-                  </a:gs>
-                </a:gsLst>
-                <a:lin ang="5400000" scaled="1"/>
-              </a:gradFill>
-              <a:latin typeface="Impact" panose="020B0806030902050204" pitchFamily="34" charset="0"/>
-            </a:endParaRPr>
-          </a:p>
-        </p:txBody>
-      </p:sp>
-      <p:sp>
-        <p:nvSpPr>
-          <p:cNvPr id="8" name="标题 1">
-            <a:extLst>
-              <a:ext uri="{FF2B5EF4-FFF2-40B4-BE49-F238E27FC236}">
-                <a16:creationId xmlns:a16="http://schemas.microsoft.com/office/drawing/2014/main" id="{ABB4B086-4071-4C4C-9FF8-B987D7306B9B}"/>
-              </a:ext>
-            </a:extLst>
-          </p:cNvPr>
-          <p:cNvSpPr txBox="1">
-            <a:spLocks/>
-          </p:cNvSpPr>
-          <p:nvPr/>
-        </p:nvSpPr>
-        <p:spPr>
-          <a:xfrm>
-            <a:off x="3069349" y="3056840"/>
-            <a:ext cx="8186902" cy="833759"/>
-          </a:xfrm>
-          <a:prstGeom prst="rect">
-            <a:avLst/>
-          </a:prstGeom>
-        </p:spPr>
-        <p:txBody>
-          <a:bodyPr lIns="0" rIns="0" bIns="0" anchor="b" anchorCtr="0">
-            <a:normAutofit/>
-          </a:bodyPr>
-          <a:lstStyle>
-            <a:lvl1pPr algn="ctr" defTabSz="914400" rtl="0" eaLnBrk="1" latinLnBrk="0" hangingPunct="1">
-              <a:lnSpc>
-                <a:spcPct val="90000"/>
-              </a:lnSpc>
-              <a:spcBef>
-                <a:spcPct val="0"/>
-              </a:spcBef>
-              <a:buNone/>
-              <a:defRPr lang="zh-CN" altLang="en-US" sz="4400" b="1" kern="1200" dirty="0">
-                <a:solidFill>
-                  <a:schemeClr val="tx1">
-                    <a:lumMod val="95000"/>
-                    <a:lumOff val="5000"/>
-                  </a:schemeClr>
-                </a:solidFill>
-                <a:latin typeface="+mj-lt"/>
-                <a:ea typeface="+mj-ea"/>
-                <a:cs typeface="+mj-cs"/>
-              </a:defRPr>
-            </a:lvl1pPr>
-          </a:lstStyle>
-          <a:p>
-            <a:r>
-              <a:rPr lang="zh-CN" altLang="en-US" dirty="0">
-                <a:solidFill>
-                  <a:srgbClr val="000000">
-                    <a:lumMod val="95000"/>
-                    <a:lumOff val="5000"/>
-                  </a:srgbClr>
-                </a:solidFill>
-                <a:latin typeface="Segoe UI"/>
-                <a:ea typeface="微软雅黑"/>
-              </a:rPr>
-              <a:t>请各位老师批评指正</a:t>
-            </a:r>
-            <a:r>
-              <a:rPr lang="en-US" altLang="zh-CN" dirty="0">
-                <a:solidFill>
-                  <a:srgbClr val="000000">
-                    <a:lumMod val="95000"/>
-                    <a:lumOff val="5000"/>
-                  </a:srgbClr>
-                </a:solidFill>
-                <a:latin typeface="Segoe UI"/>
-                <a:ea typeface="微软雅黑"/>
-              </a:rPr>
-              <a:t>!</a:t>
-            </a:r>
-            <a:endParaRPr lang="zh-CN" altLang="en-US" dirty="0"/>
-          </a:p>
-        </p:txBody>
-      </p:sp>
-    </p:spTree>
-    <p:extLst>
-      <p:ext uri="{BB962C8B-B14F-4D97-AF65-F5344CB8AC3E}">
-        <p14:creationId xmlns:p14="http://schemas.microsoft.com/office/powerpoint/2010/main" val="2931844051"/>
-      </p:ext>
-    </p:extLst>
-  </p:cSld>
-  <p:clrMapOvr>
-    <a:masterClrMapping/>
-  </p:clrMapOvr>
-  <mc:AlternateContent xmlns:mc="http://schemas.openxmlformats.org/markup-compatibility/2006" xmlns:p14="http://schemas.microsoft.com/office/powerpoint/2010/main">
-    <mc:Choice Requires="p14">
-      <p:transition spd="slow" p14:dur="2000" advTm="7305"/>
-    </mc:Choice>
-    <mc:Fallback xmlns="">
-      <p:transition spd="slow" advTm="7305"/>
-    </mc:Fallback>
-  </mc:AlternateContent>
-</p:sld>
-</file>
-
 <file path=ppt/slides/slide2.xml><?xml version="1.0" encoding="utf-8"?>
 <p:sld xmlns:a="http://schemas.openxmlformats.org/drawingml/2006/main" xmlns:r="http://schemas.openxmlformats.org/officeDocument/2006/relationships" xmlns:p="http://schemas.openxmlformats.org/presentationml/2006/main">
   <p:cSld>
@@ -10105,774 +9919,6 @@
         <p:cNvPr id="1" name="">
           <a:extLst>
             <a:ext uri="{FF2B5EF4-FFF2-40B4-BE49-F238E27FC236}">
-              <a16:creationId xmlns:a16="http://schemas.microsoft.com/office/drawing/2014/main" id="{15F3D6C7-6229-4EA2-24E0-47CB8ED4F3F1}"/>
-            </a:ext>
-          </a:extLst>
-        </p:cNvPr>
-        <p:cNvGrpSpPr/>
-        <p:nvPr/>
-      </p:nvGrpSpPr>
-      <p:grpSpPr>
-        <a:xfrm>
-          <a:off x="0" y="0"/>
-          <a:ext cx="0" cy="0"/>
-          <a:chOff x="0" y="0"/>
-          <a:chExt cx="0" cy="0"/>
-        </a:xfrm>
-      </p:grpSpPr>
-      <p:sp>
-        <p:nvSpPr>
-          <p:cNvPr id="2" name="Rectangle 1">
-            <a:extLst>
-              <a:ext uri="{FF2B5EF4-FFF2-40B4-BE49-F238E27FC236}">
-                <a16:creationId xmlns:a16="http://schemas.microsoft.com/office/drawing/2014/main" id="{3DF5B429-65FA-F424-8D1B-73A5DE716D79}"/>
-              </a:ext>
-            </a:extLst>
-          </p:cNvPr>
-          <p:cNvSpPr/>
-          <p:nvPr/>
-        </p:nvSpPr>
-        <p:spPr>
-          <a:xfrm>
-            <a:off x="0" y="857250"/>
-            <a:ext cx="7905750" cy="76200"/>
-          </a:xfrm>
-          <a:prstGeom prst="rect">
-            <a:avLst/>
-          </a:prstGeom>
-          <a:solidFill>
-            <a:srgbClr val="5B8BC6"/>
-          </a:solidFill>
-          <a:ln>
-            <a:noFill/>
-          </a:ln>
-          <a:effectLst/>
-        </p:spPr>
-        <p:style>
-          <a:lnRef idx="1">
-            <a:schemeClr val="accent1"/>
-          </a:lnRef>
-          <a:fillRef idx="3">
-            <a:schemeClr val="accent1"/>
-          </a:fillRef>
-          <a:effectRef idx="2">
-            <a:schemeClr val="accent1"/>
-          </a:effectRef>
-          <a:fontRef idx="minor">
-            <a:schemeClr val="lt1"/>
-          </a:fontRef>
-        </p:style>
-        <p:txBody>
-          <a:bodyPr rtlCol="0" anchor="ctr"/>
-          <a:lstStyle/>
-          <a:p>
-            <a:pPr algn="ctr"/>
-            <a:endParaRPr dirty="0">
-              <a:latin typeface="微软雅黑" panose="020B0503020204020204" pitchFamily="34" charset="-122"/>
-              <a:ea typeface="微软雅黑" panose="020B0503020204020204" pitchFamily="34" charset="-122"/>
-            </a:endParaRPr>
-          </a:p>
-        </p:txBody>
-      </p:sp>
-      <p:sp>
-        <p:nvSpPr>
-          <p:cNvPr id="3" name="Rectangle 2">
-            <a:extLst>
-              <a:ext uri="{FF2B5EF4-FFF2-40B4-BE49-F238E27FC236}">
-                <a16:creationId xmlns:a16="http://schemas.microsoft.com/office/drawing/2014/main" id="{52CF4261-98EB-D0A0-3671-22402AA35422}"/>
-              </a:ext>
-            </a:extLst>
-          </p:cNvPr>
-          <p:cNvSpPr/>
-          <p:nvPr/>
-        </p:nvSpPr>
-        <p:spPr>
-          <a:xfrm>
-            <a:off x="8096250" y="885825"/>
-            <a:ext cx="4095750" cy="28575"/>
-          </a:xfrm>
-          <a:prstGeom prst="rect">
-            <a:avLst/>
-          </a:prstGeom>
-          <a:solidFill>
-            <a:srgbClr val="9CC2E5"/>
-          </a:solidFill>
-          <a:ln>
-            <a:noFill/>
-          </a:ln>
-          <a:effectLst/>
-        </p:spPr>
-        <p:style>
-          <a:lnRef idx="1">
-            <a:schemeClr val="accent1"/>
-          </a:lnRef>
-          <a:fillRef idx="3">
-            <a:schemeClr val="accent1"/>
-          </a:fillRef>
-          <a:effectRef idx="2">
-            <a:schemeClr val="accent1"/>
-          </a:effectRef>
-          <a:fontRef idx="minor">
-            <a:schemeClr val="lt1"/>
-          </a:fontRef>
-        </p:style>
-        <p:txBody>
-          <a:bodyPr rtlCol="0" anchor="ctr"/>
-          <a:lstStyle/>
-          <a:p>
-            <a:pPr algn="ctr"/>
-            <a:endParaRPr dirty="0">
-              <a:latin typeface="微软雅黑" panose="020B0503020204020204" pitchFamily="34" charset="-122"/>
-              <a:ea typeface="微软雅黑" panose="020B0503020204020204" pitchFamily="34" charset="-122"/>
-            </a:endParaRPr>
-          </a:p>
-        </p:txBody>
-      </p:sp>
-      <p:pic>
-        <p:nvPicPr>
-          <p:cNvPr id="4" name="Picture 3" descr="heu_logo_color.png">
-            <a:extLst>
-              <a:ext uri="{FF2B5EF4-FFF2-40B4-BE49-F238E27FC236}">
-                <a16:creationId xmlns:a16="http://schemas.microsoft.com/office/drawing/2014/main" id="{A8C520DD-0025-520B-9B49-F2F395A7CD55}"/>
-              </a:ext>
-            </a:extLst>
-          </p:cNvPr>
-          <p:cNvPicPr>
-            <a:picLocks noChangeAspect="1"/>
-          </p:cNvPicPr>
-          <p:nvPr/>
-        </p:nvPicPr>
-        <p:blipFill>
-          <a:blip r:embed="rId2"/>
-          <a:stretch>
-            <a:fillRect/>
-          </a:stretch>
-        </p:blipFill>
-        <p:spPr>
-          <a:xfrm>
-            <a:off x="9577062" y="158750"/>
-            <a:ext cx="2329188" cy="619125"/>
-          </a:xfrm>
-          <a:prstGeom prst="rect">
-            <a:avLst/>
-          </a:prstGeom>
-        </p:spPr>
-      </p:pic>
-      <p:sp>
-        <p:nvSpPr>
-          <p:cNvPr id="5" name="Rectangle 4">
-            <a:extLst>
-              <a:ext uri="{FF2B5EF4-FFF2-40B4-BE49-F238E27FC236}">
-                <a16:creationId xmlns:a16="http://schemas.microsoft.com/office/drawing/2014/main" id="{ADDAF7B0-D7DC-8130-0EF0-AC48B46E9AF9}"/>
-              </a:ext>
-            </a:extLst>
-          </p:cNvPr>
-          <p:cNvSpPr/>
-          <p:nvPr/>
-        </p:nvSpPr>
-        <p:spPr>
-          <a:xfrm>
-            <a:off x="0" y="6473502"/>
-            <a:ext cx="12192000" cy="19050"/>
-          </a:xfrm>
-          <a:prstGeom prst="rect">
-            <a:avLst/>
-          </a:prstGeom>
-          <a:solidFill>
-            <a:srgbClr val="3E649A"/>
-          </a:solidFill>
-          <a:ln>
-            <a:noFill/>
-          </a:ln>
-          <a:effectLst/>
-        </p:spPr>
-        <p:style>
-          <a:lnRef idx="1">
-            <a:schemeClr val="accent1"/>
-          </a:lnRef>
-          <a:fillRef idx="3">
-            <a:schemeClr val="accent1"/>
-          </a:fillRef>
-          <a:effectRef idx="2">
-            <a:schemeClr val="accent1"/>
-          </a:effectRef>
-          <a:fontRef idx="minor">
-            <a:schemeClr val="lt1"/>
-          </a:fontRef>
-        </p:style>
-        <p:txBody>
-          <a:bodyPr rtlCol="0" anchor="ctr"/>
-          <a:lstStyle/>
-          <a:p>
-            <a:pPr algn="ctr"/>
-            <a:endParaRPr dirty="0">
-              <a:latin typeface="微软雅黑" panose="020B0503020204020204" pitchFamily="34" charset="-122"/>
-              <a:ea typeface="微软雅黑" panose="020B0503020204020204" pitchFamily="34" charset="-122"/>
-            </a:endParaRPr>
-          </a:p>
-        </p:txBody>
-      </p:sp>
-      <p:sp>
-        <p:nvSpPr>
-          <p:cNvPr id="6" name="TextBox 5">
-            <a:extLst>
-              <a:ext uri="{FF2B5EF4-FFF2-40B4-BE49-F238E27FC236}">
-                <a16:creationId xmlns:a16="http://schemas.microsoft.com/office/drawing/2014/main" id="{0E430AF4-3E18-1FF4-1FE8-79A9DD381B51}"/>
-              </a:ext>
-            </a:extLst>
-          </p:cNvPr>
-          <p:cNvSpPr txBox="1"/>
-          <p:nvPr/>
-        </p:nvSpPr>
-        <p:spPr>
-          <a:xfrm>
-            <a:off x="101481" y="6511806"/>
-            <a:ext cx="2087431" cy="369332"/>
-          </a:xfrm>
-          <a:prstGeom prst="rect">
-            <a:avLst/>
-          </a:prstGeom>
-          <a:noFill/>
-        </p:spPr>
-        <p:txBody>
-          <a:bodyPr wrap="none">
-            <a:spAutoFit/>
-          </a:bodyPr>
-          <a:lstStyle/>
-          <a:p>
-            <a:pPr>
-              <a:defRPr sz="1800">
-                <a:solidFill>
-                  <a:srgbClr val="1E1E1E"/>
-                </a:solidFill>
-                <a:latin typeface="KaiTi"/>
-              </a:defRPr>
-            </a:pPr>
-            <a:r>
-              <a:rPr dirty="0" err="1">
-                <a:solidFill>
-                  <a:schemeClr val="tx1">
-                    <a:lumMod val="50000"/>
-                    <a:lumOff val="50000"/>
-                  </a:schemeClr>
-                </a:solidFill>
-                <a:latin typeface="华文行楷" panose="02010800040101010101" pitchFamily="2" charset="-122"/>
-                <a:ea typeface="华文行楷" panose="02010800040101010101" pitchFamily="2" charset="-122"/>
-              </a:rPr>
-              <a:t>大工至善</a:t>
-            </a:r>
-            <a:r>
-              <a:rPr dirty="0">
-                <a:solidFill>
-                  <a:schemeClr val="tx1">
-                    <a:lumMod val="50000"/>
-                    <a:lumOff val="50000"/>
-                  </a:schemeClr>
-                </a:solidFill>
-                <a:latin typeface="华文行楷" panose="02010800040101010101" pitchFamily="2" charset="-122"/>
-                <a:ea typeface="华文行楷" panose="02010800040101010101" pitchFamily="2" charset="-122"/>
-              </a:rPr>
-              <a:t> </a:t>
-            </a:r>
-            <a:r>
-              <a:rPr dirty="0" err="1">
-                <a:solidFill>
-                  <a:schemeClr val="tx1">
-                    <a:lumMod val="50000"/>
-                    <a:lumOff val="50000"/>
-                  </a:schemeClr>
-                </a:solidFill>
-                <a:latin typeface="华文行楷" panose="02010800040101010101" pitchFamily="2" charset="-122"/>
-                <a:ea typeface="华文行楷" panose="02010800040101010101" pitchFamily="2" charset="-122"/>
-              </a:rPr>
-              <a:t>大学至真</a:t>
-            </a:r>
-            <a:endParaRPr dirty="0">
-              <a:solidFill>
-                <a:schemeClr val="tx1">
-                  <a:lumMod val="50000"/>
-                  <a:lumOff val="50000"/>
-                </a:schemeClr>
-              </a:solidFill>
-              <a:latin typeface="华文行楷" panose="02010800040101010101" pitchFamily="2" charset="-122"/>
-              <a:ea typeface="华文行楷" panose="02010800040101010101" pitchFamily="2" charset="-122"/>
-            </a:endParaRPr>
-          </a:p>
-        </p:txBody>
-      </p:sp>
-      <p:sp>
-        <p:nvSpPr>
-          <p:cNvPr id="8" name="灯片编号占位符 7">
-            <a:extLst>
-              <a:ext uri="{FF2B5EF4-FFF2-40B4-BE49-F238E27FC236}">
-                <a16:creationId xmlns:a16="http://schemas.microsoft.com/office/drawing/2014/main" id="{DD61A4E1-A578-CAB9-3102-854F81535B1F}"/>
-              </a:ext>
-            </a:extLst>
-          </p:cNvPr>
-          <p:cNvSpPr>
-            <a:spLocks noGrp="1"/>
-          </p:cNvSpPr>
-          <p:nvPr>
-            <p:ph type="sldNum" sz="quarter" idx="12"/>
-          </p:nvPr>
-        </p:nvSpPr>
-        <p:spPr>
-          <a:xfrm>
-            <a:off x="11423769" y="6492875"/>
-            <a:ext cx="482481" cy="365125"/>
-          </a:xfrm>
-        </p:spPr>
-        <p:txBody>
-          <a:bodyPr/>
-          <a:lstStyle/>
-          <a:p>
-            <a:fld id="{C1FF6DA9-008F-8B48-92A6-B652298478BF}" type="slidenum">
-              <a:rPr lang="en-US" sz="1400" smtClean="0">
-                <a:latin typeface="Times New Roman" panose="02020603050405020304" pitchFamily="18" charset="0"/>
-                <a:cs typeface="Times New Roman" panose="02020603050405020304" pitchFamily="18" charset="0"/>
-              </a:rPr>
-              <a:t>8</a:t>
-            </a:fld>
-            <a:endParaRPr lang="en-US" sz="1400" dirty="0">
-              <a:latin typeface="Times New Roman" panose="02020603050405020304" pitchFamily="18" charset="0"/>
-              <a:cs typeface="Times New Roman" panose="02020603050405020304" pitchFamily="18" charset="0"/>
-            </a:endParaRPr>
-          </a:p>
-        </p:txBody>
-      </p:sp>
-      <p:sp>
-        <p:nvSpPr>
-          <p:cNvPr id="12" name="文本框 11">
-            <a:extLst>
-              <a:ext uri="{FF2B5EF4-FFF2-40B4-BE49-F238E27FC236}">
-                <a16:creationId xmlns:a16="http://schemas.microsoft.com/office/drawing/2014/main" id="{5D56BA18-1F82-188B-B971-038A51D43426}"/>
-              </a:ext>
-            </a:extLst>
-          </p:cNvPr>
-          <p:cNvSpPr txBox="1"/>
-          <p:nvPr/>
-        </p:nvSpPr>
-        <p:spPr>
-          <a:xfrm>
-            <a:off x="298569" y="1063020"/>
-            <a:ext cx="6097424" cy="400110"/>
-          </a:xfrm>
-          <a:prstGeom prst="rect">
-            <a:avLst/>
-          </a:prstGeom>
-          <a:noFill/>
-        </p:spPr>
-        <p:txBody>
-          <a:bodyPr wrap="square">
-            <a:spAutoFit/>
-          </a:bodyPr>
-          <a:lstStyle/>
-          <a:p>
-            <a:r>
-              <a:rPr lang="zh-CN" altLang="en-US" sz="2000" b="1" i="0" dirty="0">
-                <a:solidFill>
-                  <a:srgbClr val="000000"/>
-                </a:solidFill>
-                <a:effectLst/>
-                <a:latin typeface="微软雅黑" panose="020B0503020204020204" pitchFamily="34" charset="-122"/>
-                <a:ea typeface="微软雅黑" panose="020B0503020204020204" pitchFamily="34" charset="-122"/>
-              </a:rPr>
-              <a:t>➢ 小标题</a:t>
-            </a:r>
-            <a:endParaRPr lang="zh-CN" altLang="en-US" sz="2000" dirty="0">
-              <a:latin typeface="微软雅黑" panose="020B0503020204020204" pitchFamily="34" charset="-122"/>
-              <a:ea typeface="微软雅黑" panose="020B0503020204020204" pitchFamily="34" charset="-122"/>
-            </a:endParaRPr>
-          </a:p>
-        </p:txBody>
-      </p:sp>
-      <p:sp>
-        <p:nvSpPr>
-          <p:cNvPr id="16" name="文本框 15">
-            <a:extLst>
-              <a:ext uri="{FF2B5EF4-FFF2-40B4-BE49-F238E27FC236}">
-                <a16:creationId xmlns:a16="http://schemas.microsoft.com/office/drawing/2014/main" id="{599A948A-7E0A-7CCC-5565-58180F1FAF4C}"/>
-              </a:ext>
-            </a:extLst>
-          </p:cNvPr>
-          <p:cNvSpPr txBox="1"/>
-          <p:nvPr/>
-        </p:nvSpPr>
-        <p:spPr>
-          <a:xfrm>
-            <a:off x="298569" y="163534"/>
-            <a:ext cx="6097424" cy="584775"/>
-          </a:xfrm>
-          <a:prstGeom prst="rect">
-            <a:avLst/>
-          </a:prstGeom>
-          <a:noFill/>
-        </p:spPr>
-        <p:txBody>
-          <a:bodyPr wrap="square">
-            <a:spAutoFit/>
-          </a:bodyPr>
-          <a:lstStyle/>
-          <a:p>
-            <a:pPr algn="l">
-              <a:buNone/>
-            </a:pPr>
-            <a:r>
-              <a:rPr lang="en-US" altLang="zh-CN" sz="3200" b="1" i="0" dirty="0">
-                <a:solidFill>
-                  <a:srgbClr val="4472C4"/>
-                </a:solidFill>
-                <a:effectLst/>
-                <a:latin typeface="微软雅黑" panose="020B0503020204020204" pitchFamily="34" charset="-122"/>
-                <a:ea typeface="微软雅黑" panose="020B0503020204020204" pitchFamily="34" charset="-122"/>
-              </a:rPr>
-              <a:t>03 </a:t>
-            </a:r>
-            <a:r>
-              <a:rPr lang="zh-CN" altLang="en-US" sz="3200" b="1" i="0" dirty="0">
-                <a:solidFill>
-                  <a:srgbClr val="4472C4"/>
-                </a:solidFill>
-                <a:effectLst/>
-                <a:latin typeface="微软雅黑" panose="020B0503020204020204" pitchFamily="34" charset="-122"/>
-                <a:ea typeface="微软雅黑" panose="020B0503020204020204" pitchFamily="34" charset="-122"/>
-              </a:rPr>
-              <a:t>模板</a:t>
-            </a:r>
-            <a:r>
-              <a:rPr lang="en-US" altLang="zh-CN" sz="3200" b="1" dirty="0">
-                <a:solidFill>
-                  <a:srgbClr val="4472C4"/>
-                </a:solidFill>
-                <a:latin typeface="微软雅黑" panose="020B0503020204020204" pitchFamily="34" charset="-122"/>
-                <a:ea typeface="微软雅黑" panose="020B0503020204020204" pitchFamily="34" charset="-122"/>
-              </a:rPr>
-              <a:t>5</a:t>
-            </a:r>
-            <a:endParaRPr lang="zh-CN" altLang="en-US" sz="3200" b="1" i="0" dirty="0">
-              <a:solidFill>
-                <a:srgbClr val="4472C4"/>
-              </a:solidFill>
-              <a:effectLst/>
-              <a:latin typeface="微软雅黑" panose="020B0503020204020204" pitchFamily="34" charset="-122"/>
-              <a:ea typeface="微软雅黑" panose="020B0503020204020204" pitchFamily="34" charset="-122"/>
-            </a:endParaRPr>
-          </a:p>
-        </p:txBody>
-      </p:sp>
-      <p:sp>
-        <p:nvSpPr>
-          <p:cNvPr id="18" name="矩形 17">
-            <a:extLst>
-              <a:ext uri="{FF2B5EF4-FFF2-40B4-BE49-F238E27FC236}">
-                <a16:creationId xmlns:a16="http://schemas.microsoft.com/office/drawing/2014/main" id="{AEE27A01-3230-85B5-A330-1E6787DA6FE3}"/>
-              </a:ext>
-            </a:extLst>
-          </p:cNvPr>
-          <p:cNvSpPr/>
-          <p:nvPr/>
-        </p:nvSpPr>
-        <p:spPr>
-          <a:xfrm>
-            <a:off x="6931347" y="1280663"/>
-            <a:ext cx="4733662" cy="4720087"/>
-          </a:xfrm>
-          <a:prstGeom prst="rect">
-            <a:avLst/>
-          </a:prstGeom>
-          <a:solidFill>
-            <a:schemeClr val="accent1">
-              <a:lumMod val="60000"/>
-              <a:lumOff val="40000"/>
-            </a:schemeClr>
-          </a:solidFill>
-        </p:spPr>
-        <p:style>
-          <a:lnRef idx="1">
-            <a:schemeClr val="accent1"/>
-          </a:lnRef>
-          <a:fillRef idx="3">
-            <a:schemeClr val="accent1"/>
-          </a:fillRef>
-          <a:effectRef idx="2">
-            <a:schemeClr val="accent1"/>
-          </a:effectRef>
-          <a:fontRef idx="minor">
-            <a:schemeClr val="lt1"/>
-          </a:fontRef>
-        </p:style>
-        <p:txBody>
-          <a:bodyPr rtlCol="0" anchor="ctr"/>
-          <a:lstStyle/>
-          <a:p>
-            <a:pPr algn="ctr"/>
-            <a:r>
-              <a:rPr lang="zh-CN" altLang="en-US" dirty="0"/>
-              <a:t>图片</a:t>
-            </a:r>
-            <a:r>
-              <a:rPr lang="en-US" altLang="zh-CN" dirty="0"/>
-              <a:t>1</a:t>
-            </a:r>
-            <a:endParaRPr lang="zh-CN" altLang="en-US" dirty="0"/>
-          </a:p>
-        </p:txBody>
-      </p:sp>
-      <p:sp>
-        <p:nvSpPr>
-          <p:cNvPr id="7" name="文本框 6">
-            <a:extLst>
-              <a:ext uri="{FF2B5EF4-FFF2-40B4-BE49-F238E27FC236}">
-                <a16:creationId xmlns:a16="http://schemas.microsoft.com/office/drawing/2014/main" id="{6B5D4241-8E34-675A-F3D0-305D8ED707D3}"/>
-              </a:ext>
-            </a:extLst>
-          </p:cNvPr>
-          <p:cNvSpPr txBox="1"/>
-          <p:nvPr/>
-        </p:nvSpPr>
-        <p:spPr>
-          <a:xfrm>
-            <a:off x="499669" y="1742197"/>
-            <a:ext cx="5473291" cy="4016484"/>
-          </a:xfrm>
-          <a:prstGeom prst="rect">
-            <a:avLst/>
-          </a:prstGeom>
-          <a:solidFill>
-            <a:schemeClr val="accent1">
-              <a:lumMod val="20000"/>
-              <a:lumOff val="80000"/>
-            </a:schemeClr>
-          </a:solidFill>
-        </p:spPr>
-        <p:txBody>
-          <a:bodyPr wrap="square">
-            <a:spAutoFit/>
-          </a:bodyPr>
-          <a:lstStyle/>
-          <a:p>
-            <a:pPr marL="285750" indent="-285750">
-              <a:spcBef>
-                <a:spcPts val="375"/>
-              </a:spcBef>
-              <a:spcAft>
-                <a:spcPts val="600"/>
-              </a:spcAft>
-              <a:buFont typeface="Wingdings" panose="05000000000000000000" pitchFamily="2" charset="2"/>
-              <a:buChar char="n"/>
-            </a:pPr>
-            <a:r>
-              <a:rPr lang="zh-CN" altLang="en-US" dirty="0">
-                <a:solidFill>
-                  <a:srgbClr val="000000"/>
-                </a:solidFill>
-                <a:latin typeface="微软雅黑" panose="020B0503020204020204" pitchFamily="34" charset="-122"/>
-                <a:ea typeface="微软雅黑" panose="020B0503020204020204" pitchFamily="34" charset="-122"/>
-              </a:rPr>
-              <a:t>描述性文字</a:t>
-            </a:r>
-            <a:endParaRPr lang="en-US" altLang="zh-CN" dirty="0">
-              <a:solidFill>
-                <a:srgbClr val="000000"/>
-              </a:solidFill>
-              <a:latin typeface="微软雅黑" panose="020B0503020204020204" pitchFamily="34" charset="-122"/>
-              <a:ea typeface="微软雅黑" panose="020B0503020204020204" pitchFamily="34" charset="-122"/>
-            </a:endParaRPr>
-          </a:p>
-          <a:p>
-            <a:pPr marL="285750" indent="-285750">
-              <a:spcBef>
-                <a:spcPts val="375"/>
-              </a:spcBef>
-              <a:spcAft>
-                <a:spcPts val="600"/>
-              </a:spcAft>
-              <a:buFont typeface="Wingdings" panose="05000000000000000000" pitchFamily="2" charset="2"/>
-              <a:buChar char="n"/>
-            </a:pPr>
-            <a:endParaRPr lang="en-US" altLang="zh-CN" dirty="0">
-              <a:solidFill>
-                <a:srgbClr val="000000"/>
-              </a:solidFill>
-              <a:latin typeface="微软雅黑" panose="020B0503020204020204" pitchFamily="34" charset="-122"/>
-              <a:ea typeface="微软雅黑" panose="020B0503020204020204" pitchFamily="34" charset="-122"/>
-            </a:endParaRPr>
-          </a:p>
-          <a:p>
-            <a:pPr marL="285750" indent="-285750">
-              <a:spcBef>
-                <a:spcPts val="375"/>
-              </a:spcBef>
-              <a:spcAft>
-                <a:spcPts val="600"/>
-              </a:spcAft>
-              <a:buFont typeface="Wingdings" panose="05000000000000000000" pitchFamily="2" charset="2"/>
-              <a:buChar char="n"/>
-            </a:pPr>
-            <a:endParaRPr lang="en-US" altLang="zh-CN" dirty="0">
-              <a:solidFill>
-                <a:srgbClr val="000000"/>
-              </a:solidFill>
-              <a:latin typeface="微软雅黑" panose="020B0503020204020204" pitchFamily="34" charset="-122"/>
-              <a:ea typeface="微软雅黑" panose="020B0503020204020204" pitchFamily="34" charset="-122"/>
-            </a:endParaRPr>
-          </a:p>
-          <a:p>
-            <a:pPr marL="285750" indent="-285750">
-              <a:spcBef>
-                <a:spcPts val="375"/>
-              </a:spcBef>
-              <a:spcAft>
-                <a:spcPts val="600"/>
-              </a:spcAft>
-              <a:buFont typeface="Wingdings" panose="05000000000000000000" pitchFamily="2" charset="2"/>
-              <a:buChar char="n"/>
-            </a:pPr>
-            <a:endParaRPr lang="en-US" altLang="zh-CN" dirty="0">
-              <a:solidFill>
-                <a:srgbClr val="000000"/>
-              </a:solidFill>
-              <a:latin typeface="微软雅黑" panose="020B0503020204020204" pitchFamily="34" charset="-122"/>
-              <a:ea typeface="微软雅黑" panose="020B0503020204020204" pitchFamily="34" charset="-122"/>
-            </a:endParaRPr>
-          </a:p>
-          <a:p>
-            <a:pPr marL="285750" indent="-285750">
-              <a:spcBef>
-                <a:spcPts val="375"/>
-              </a:spcBef>
-              <a:spcAft>
-                <a:spcPts val="600"/>
-              </a:spcAft>
-              <a:buFont typeface="Wingdings" panose="05000000000000000000" pitchFamily="2" charset="2"/>
-              <a:buChar char="n"/>
-            </a:pPr>
-            <a:endParaRPr lang="en-US" altLang="zh-CN" dirty="0">
-              <a:solidFill>
-                <a:srgbClr val="000000"/>
-              </a:solidFill>
-              <a:latin typeface="微软雅黑" panose="020B0503020204020204" pitchFamily="34" charset="-122"/>
-              <a:ea typeface="微软雅黑" panose="020B0503020204020204" pitchFamily="34" charset="-122"/>
-            </a:endParaRPr>
-          </a:p>
-          <a:p>
-            <a:pPr marL="285750" indent="-285750">
-              <a:spcBef>
-                <a:spcPts val="375"/>
-              </a:spcBef>
-              <a:spcAft>
-                <a:spcPts val="600"/>
-              </a:spcAft>
-              <a:buFont typeface="Wingdings" panose="05000000000000000000" pitchFamily="2" charset="2"/>
-              <a:buChar char="n"/>
-            </a:pPr>
-            <a:endParaRPr lang="en-US" altLang="zh-CN" dirty="0">
-              <a:solidFill>
-                <a:srgbClr val="000000"/>
-              </a:solidFill>
-              <a:latin typeface="微软雅黑" panose="020B0503020204020204" pitchFamily="34" charset="-122"/>
-              <a:ea typeface="微软雅黑" panose="020B0503020204020204" pitchFamily="34" charset="-122"/>
-            </a:endParaRPr>
-          </a:p>
-          <a:p>
-            <a:pPr marL="285750" indent="-285750">
-              <a:spcBef>
-                <a:spcPts val="375"/>
-              </a:spcBef>
-              <a:spcAft>
-                <a:spcPts val="600"/>
-              </a:spcAft>
-              <a:buFont typeface="Wingdings" panose="05000000000000000000" pitchFamily="2" charset="2"/>
-              <a:buChar char="n"/>
-            </a:pPr>
-            <a:endParaRPr lang="en-US" altLang="zh-CN" dirty="0">
-              <a:solidFill>
-                <a:srgbClr val="000000"/>
-              </a:solidFill>
-              <a:latin typeface="微软雅黑" panose="020B0503020204020204" pitchFamily="34" charset="-122"/>
-              <a:ea typeface="微软雅黑" panose="020B0503020204020204" pitchFamily="34" charset="-122"/>
-            </a:endParaRPr>
-          </a:p>
-          <a:p>
-            <a:pPr marL="285750" indent="-285750">
-              <a:spcBef>
-                <a:spcPts val="375"/>
-              </a:spcBef>
-              <a:spcAft>
-                <a:spcPts val="600"/>
-              </a:spcAft>
-              <a:buFont typeface="Wingdings" panose="05000000000000000000" pitchFamily="2" charset="2"/>
-              <a:buChar char="n"/>
-            </a:pPr>
-            <a:endParaRPr lang="en-US" altLang="zh-CN" dirty="0">
-              <a:solidFill>
-                <a:srgbClr val="000000"/>
-              </a:solidFill>
-              <a:latin typeface="微软雅黑" panose="020B0503020204020204" pitchFamily="34" charset="-122"/>
-              <a:ea typeface="微软雅黑" panose="020B0503020204020204" pitchFamily="34" charset="-122"/>
-            </a:endParaRPr>
-          </a:p>
-          <a:p>
-            <a:pPr marL="285750" indent="-285750">
-              <a:spcBef>
-                <a:spcPts val="375"/>
-              </a:spcBef>
-              <a:spcAft>
-                <a:spcPts val="600"/>
-              </a:spcAft>
-              <a:buFont typeface="Wingdings" panose="05000000000000000000" pitchFamily="2" charset="2"/>
-              <a:buChar char="n"/>
-            </a:pPr>
-            <a:endParaRPr lang="en-US" altLang="zh-CN" dirty="0">
-              <a:solidFill>
-                <a:srgbClr val="000000"/>
-              </a:solidFill>
-              <a:latin typeface="微软雅黑" panose="020B0503020204020204" pitchFamily="34" charset="-122"/>
-              <a:ea typeface="微软雅黑" panose="020B0503020204020204" pitchFamily="34" charset="-122"/>
-            </a:endParaRPr>
-          </a:p>
-          <a:p>
-            <a:pPr marL="285750" indent="-285750">
-              <a:spcBef>
-                <a:spcPts val="375"/>
-              </a:spcBef>
-              <a:spcAft>
-                <a:spcPts val="600"/>
-              </a:spcAft>
-              <a:buFont typeface="Wingdings" panose="05000000000000000000" pitchFamily="2" charset="2"/>
-              <a:buChar char="n"/>
-            </a:pPr>
-            <a:endParaRPr lang="en-US" altLang="zh-CN" dirty="0">
-              <a:solidFill>
-                <a:srgbClr val="000000"/>
-              </a:solidFill>
-              <a:latin typeface="微软雅黑" panose="020B0503020204020204" pitchFamily="34" charset="-122"/>
-              <a:ea typeface="微软雅黑" panose="020B0503020204020204" pitchFamily="34" charset="-122"/>
-            </a:endParaRPr>
-          </a:p>
-        </p:txBody>
-      </p:sp>
-    </p:spTree>
-    <p:extLst>
-      <p:ext uri="{BB962C8B-B14F-4D97-AF65-F5344CB8AC3E}">
-        <p14:creationId xmlns:p14="http://schemas.microsoft.com/office/powerpoint/2010/main" val="1239588936"/>
-      </p:ext>
-    </p:extLst>
-  </p:cSld>
-  <p:clrMapOvr>
-    <a:masterClrMapping/>
-  </p:clrMapOvr>
-</p:sld>
-</file>
-
-<file path=ppt/slides/slide9.xml><?xml version="1.0" encoding="utf-8"?>
-<p:sld xmlns:a="http://schemas.openxmlformats.org/drawingml/2006/main" xmlns:r="http://schemas.openxmlformats.org/officeDocument/2006/relationships" xmlns:p="http://schemas.openxmlformats.org/presentationml/2006/main">
-  <p:cSld>
-    <p:spTree>
-      <p:nvGrpSpPr>
-        <p:cNvPr id="1" name="">
-          <a:extLst>
-            <a:ext uri="{FF2B5EF4-FFF2-40B4-BE49-F238E27FC236}">
               <a16:creationId xmlns:a16="http://schemas.microsoft.com/office/drawing/2014/main" id="{C884A71F-F73C-80FE-DAF2-2098CF73C07A}"/>
             </a:ext>
           </a:extLst>
@@ -11199,7 +10245,7 @@
                 <a:latin typeface="Times New Roman" panose="02020603050405020304" pitchFamily="18" charset="0"/>
                 <a:cs typeface="Times New Roman" panose="02020603050405020304" pitchFamily="18" charset="0"/>
               </a:rPr>
-              <a:t>9</a:t>
+              <a:t>8</a:t>
             </a:fld>
             <a:endParaRPr lang="en-US" sz="1400" dirty="0">
               <a:latin typeface="Times New Roman" panose="02020603050405020304" pitchFamily="18" charset="0"/>
@@ -11634,6 +10680,191 @@
   <p:clrMapOvr>
     <a:masterClrMapping/>
   </p:clrMapOvr>
+</p:sld>
+</file>
+
+<file path=ppt/slides/slide9.xml><?xml version="1.0" encoding="utf-8"?>
+<p:sld xmlns:a="http://schemas.openxmlformats.org/drawingml/2006/main" xmlns:r="http://schemas.openxmlformats.org/officeDocument/2006/relationships" xmlns:p="http://schemas.openxmlformats.org/presentationml/2006/main">
+  <p:cSld>
+    <p:spTree>
+      <p:nvGrpSpPr>
+        <p:cNvPr id="1" name=""/>
+        <p:cNvGrpSpPr/>
+        <p:nvPr/>
+      </p:nvGrpSpPr>
+      <p:grpSpPr>
+        <a:xfrm>
+          <a:off x="0" y="0"/>
+          <a:ext cx="0" cy="0"/>
+          <a:chOff x="0" y="0"/>
+          <a:chExt cx="0" cy="0"/>
+        </a:xfrm>
+      </p:grpSpPr>
+      <p:sp>
+        <p:nvSpPr>
+          <p:cNvPr id="7" name="文本框 6">
+            <a:extLst>
+              <a:ext uri="{FF2B5EF4-FFF2-40B4-BE49-F238E27FC236}">
+                <a16:creationId xmlns:a16="http://schemas.microsoft.com/office/drawing/2014/main" id="{66A19AAD-1CDF-4899-8D9B-772D397CF09A}"/>
+              </a:ext>
+            </a:extLst>
+          </p:cNvPr>
+          <p:cNvSpPr txBox="1"/>
+          <p:nvPr/>
+        </p:nvSpPr>
+        <p:spPr>
+          <a:xfrm>
+            <a:off x="2170700" y="2395120"/>
+            <a:ext cx="9758680" cy="1323439"/>
+          </a:xfrm>
+          <a:prstGeom prst="rect">
+            <a:avLst/>
+          </a:prstGeom>
+          <a:noFill/>
+        </p:spPr>
+        <p:txBody>
+          <a:bodyPr wrap="square" rtlCol="0">
+            <a:spAutoFit/>
+          </a:bodyPr>
+          <a:lstStyle/>
+          <a:p>
+            <a:pPr algn="ctr"/>
+            <a:r>
+              <a:rPr lang="en-US" altLang="zh-CN" sz="8000" dirty="0">
+                <a:gradFill>
+                  <a:gsLst>
+                    <a:gs pos="0">
+                      <a:schemeClr val="accent1"/>
+                    </a:gs>
+                    <a:gs pos="100000">
+                      <a:schemeClr val="bg1">
+                        <a:alpha val="0"/>
+                      </a:schemeClr>
+                    </a:gs>
+                  </a:gsLst>
+                  <a:lin ang="5400000" scaled="1"/>
+                </a:gradFill>
+                <a:latin typeface="Impact" panose="020B0806030902050204" pitchFamily="34" charset="0"/>
+              </a:rPr>
+              <a:t>THANKS FOR LISTENING</a:t>
+            </a:r>
+            <a:endParaRPr lang="zh-CN" altLang="en-US" sz="8000" dirty="0">
+              <a:gradFill>
+                <a:gsLst>
+                  <a:gs pos="0">
+                    <a:schemeClr val="accent1"/>
+                  </a:gs>
+                  <a:gs pos="100000">
+                    <a:schemeClr val="bg1">
+                      <a:alpha val="0"/>
+                    </a:schemeClr>
+                  </a:gs>
+                </a:gsLst>
+                <a:lin ang="5400000" scaled="1"/>
+              </a:gradFill>
+              <a:latin typeface="Impact" panose="020B0806030902050204" pitchFamily="34" charset="0"/>
+            </a:endParaRPr>
+          </a:p>
+        </p:txBody>
+      </p:sp>
+      <p:sp>
+        <p:nvSpPr>
+          <p:cNvPr id="8" name="标题 1">
+            <a:extLst>
+              <a:ext uri="{FF2B5EF4-FFF2-40B4-BE49-F238E27FC236}">
+                <a16:creationId xmlns:a16="http://schemas.microsoft.com/office/drawing/2014/main" id="{ABB4B086-4071-4C4C-9FF8-B987D7306B9B}"/>
+              </a:ext>
+            </a:extLst>
+          </p:cNvPr>
+          <p:cNvSpPr txBox="1">
+            <a:spLocks/>
+          </p:cNvSpPr>
+          <p:nvPr/>
+        </p:nvSpPr>
+        <p:spPr>
+          <a:xfrm>
+            <a:off x="3069349" y="3056840"/>
+            <a:ext cx="8186902" cy="833759"/>
+          </a:xfrm>
+          <a:prstGeom prst="rect">
+            <a:avLst/>
+          </a:prstGeom>
+        </p:spPr>
+        <p:txBody>
+          <a:bodyPr lIns="0" rIns="0" bIns="0" anchor="b" anchorCtr="0">
+            <a:normAutofit/>
+          </a:bodyPr>
+          <a:lstStyle>
+            <a:lvl1pPr algn="ctr" defTabSz="914400" rtl="0" eaLnBrk="1" latinLnBrk="0" hangingPunct="1">
+              <a:lnSpc>
+                <a:spcPct val="90000"/>
+              </a:lnSpc>
+              <a:spcBef>
+                <a:spcPct val="0"/>
+              </a:spcBef>
+              <a:buNone/>
+              <a:defRPr lang="zh-CN" altLang="en-US" sz="4400" b="1" kern="1200" dirty="0">
+                <a:solidFill>
+                  <a:schemeClr val="tx1">
+                    <a:lumMod val="95000"/>
+                    <a:lumOff val="5000"/>
+                  </a:schemeClr>
+                </a:solidFill>
+                <a:latin typeface="+mj-lt"/>
+                <a:ea typeface="+mj-ea"/>
+                <a:cs typeface="+mj-cs"/>
+              </a:defRPr>
+            </a:lvl1pPr>
+          </a:lstStyle>
+          <a:p>
+            <a:r>
+              <a:rPr lang="zh-CN" altLang="en-US" dirty="0">
+                <a:solidFill>
+                  <a:srgbClr val="000000">
+                    <a:lumMod val="95000"/>
+                    <a:lumOff val="5000"/>
+                  </a:srgbClr>
+                </a:solidFill>
+                <a:latin typeface="Segoe UI"/>
+                <a:ea typeface="微软雅黑"/>
+              </a:rPr>
+              <a:t>请各位老师批评指正</a:t>
+            </a:r>
+            <a:r>
+              <a:rPr lang="en-US" altLang="zh-CN" dirty="0">
+                <a:solidFill>
+                  <a:srgbClr val="000000">
+                    <a:lumMod val="95000"/>
+                    <a:lumOff val="5000"/>
+                  </a:srgbClr>
+                </a:solidFill>
+                <a:latin typeface="Segoe UI"/>
+                <a:ea typeface="微软雅黑"/>
+              </a:rPr>
+              <a:t>!</a:t>
+            </a:r>
+            <a:endParaRPr lang="zh-CN" altLang="en-US" dirty="0"/>
+          </a:p>
+        </p:txBody>
+      </p:sp>
+    </p:spTree>
+    <p:extLst>
+      <p:ext uri="{BB962C8B-B14F-4D97-AF65-F5344CB8AC3E}">
+        <p14:creationId xmlns:p14="http://schemas.microsoft.com/office/powerpoint/2010/main" val="2931844051"/>
+      </p:ext>
+    </p:extLst>
+  </p:cSld>
+  <p:clrMapOvr>
+    <a:masterClrMapping/>
+  </p:clrMapOvr>
+  <mc:AlternateContent xmlns:mc="http://schemas.openxmlformats.org/markup-compatibility/2006" xmlns:p14="http://schemas.microsoft.com/office/powerpoint/2010/main">
+    <mc:Choice Requires="p14">
+      <p:transition spd="slow" p14:dur="2000" advTm="7305"/>
+    </mc:Choice>
+    <mc:Fallback xmlns="">
+      <p:transition spd="slow" advTm="7305"/>
+    </mc:Fallback>
+  </mc:AlternateContent>
 </p:sld>
 </file>
 

</xml_diff>